<commit_message>
style: set the deck typeface to Fira Sans
Swaps the major and minor latin typefaces in ppt/theme/theme1.xml and
theme2.xml from Arial to Fira Sans, so every placeholder, table and text
box inherits it without per-run font assignment in the renderer.

Fira Sans Regular measures 0.484 em average advance against Arial's 0.485
over an English letter-frequency sample, so PROPORTIONAL_ADVANCE stays at
its pessimistic 0.55 and the fit budgets carry over unchanged. Caps are
narrower (W 0.826 against 0.944), which gives headings more slack rather
than less.

Fira Sans Regular through Bold are installed locally, so the PowerPoint
render proof will not substitute.
</commit_message>
<xml_diff>
--- a/template.pptx
+++ b/template.pptx
@@ -5254,7 +5254,7 @@
     </a:clrScheme>
     <a:fontScheme name="Office">
       <a:majorFont>
-        <a:latin typeface="Arial"/>
+        <a:latin typeface="Fira Sans"/>
         <a:ea typeface=""/>
         <a:cs typeface=""/>
         <a:font script="Jpan" typeface="ＭＳ Ｐゴシック"/>
@@ -5289,7 +5289,7 @@
         <a:font script="Geor" typeface="Sylfaen"/>
       </a:majorFont>
       <a:minorFont>
-        <a:latin typeface="Arial"/>
+        <a:latin typeface="Fira Sans"/>
         <a:ea typeface=""/>
         <a:cs typeface=""/>
         <a:font script="Jpan" typeface="ＭＳ Ｐゴシック"/>
@@ -5535,7 +5535,7 @@
     </a:clrScheme>
     <a:fontScheme name="Office">
       <a:majorFont>
-        <a:latin typeface="Arial"/>
+        <a:latin typeface="Fira Sans"/>
         <a:ea typeface=""/>
         <a:cs typeface=""/>
         <a:font script="Jpan" typeface="ＭＳ Ｐゴシック"/>
@@ -5570,7 +5570,7 @@
         <a:font script="Geor" typeface="Sylfaen"/>
       </a:majorFont>
       <a:minorFont>
-        <a:latin typeface="Arial"/>
+        <a:latin typeface="Fira Sans"/>
         <a:ea typeface=""/>
         <a:cs typeface=""/>
         <a:font script="Jpan" typeface="ＭＳ Ｐゴシック"/>

</xml_diff>